<commit_message>
Pakistan-only data guard; single Location select; remove Telegram from materials; update README
</commit_message>
<xml_diff>
--- a/SaafHawa_Pitch.pptx
+++ b/SaafHawa_Pitch.pptx
@@ -3226,7 +3226,7 @@
       </p:sp>
       <p:pic>
         <p:nvPicPr>
-          <p:cNvPr id="4" name="Image 0" descr="/home/claude/saafhawa/assets/architecture.png"/>
+          <p:cNvPr id="5" name="Picture 4" descr="architecture"/>
           <p:cNvPicPr>
             <a:picLocks noChangeAspect="1"/>
           </p:cNvPicPr>
@@ -3240,8 +3240,8 @@
         </p:blipFill>
         <p:spPr>
           <a:xfrm>
-            <a:off x="2441002" y="1645920"/>
-            <a:ext cx="7279516" cy="4663440"/>
+            <a:off x="1275715" y="1517650"/>
+            <a:ext cx="9044940" cy="5067935"/>
           </a:xfrm>
           <a:prstGeom prst="rect">
             <a:avLst/>
@@ -5473,7 +5473,7 @@
                 <a:ea typeface="Calibri" panose="020F0502020204030204" pitchFamily="34" charset="-122"/>
                 <a:cs typeface="Calibri" panose="020F0502020204030204" pitchFamily="34" charset="-120"/>
               </a:rPr>
-              <a:t>SaafHawa  ·  صاف ہوا  ·  github.com/mmoneka11/saafhawa</a:t>
+              <a:t>SaafHawa  ·  صاف ہوا  ·  github.com/mmoneka11/SaafHawa</a:t>
             </a:r>
             <a:endParaRPr lang="en-US" sz="1300" dirty="0"/>
           </a:p>

</xml_diff>